<commit_message>
Add building-style slide; put the priority student in the scored tier; drop the AI label
The priority student (C) now has a score and sits in Tầng 1, so the example
shows the reserve seat pulling a lower-ranked scored student past a higher-ranked
one (B). Checked against club_choice_function: capacity 2, reserve 1 -> C, A;
without a priority student -> A, B. Both slides use the same example.

Co-Authored-By: Claude Sonnet 5.5 <noreply@anthropic.com>
Claude-Session: https://claude.ai/code/session_01L2hpTTGpZu8zzQgNd4hRXM
</commit_message>
<xml_diff>
--- a/slide/mo_hinh_hai_tang_suat_uu_tien.pptx
+++ b/slide/mo_hinh_hai_tang_suat_uu_tien.pptx
@@ -502,7 +502,7 @@
           <a:p>
             <a:r>
               <a:rPr lang="en-US" dirty="0"/>
-              <a:t>Ví dụ chạy thật bằng hàm lựa chọn của phần mềm (club_choice_function): 6 em A–F cùng đăng ký một CLB, sức chứa 3, 1 suất dự trữ (ưu tiên), chỉ D thuộc diện ưu tiên. Xếp hạng: Tầng 1 (đã thi) theo điểm, hoà điểm mới tới số bốc thăm; Tầng 2 (không thi) thuần số bốc thăm; Tầng 1 luôn trước Tầng 2. Chia suất hai lượt: lượt 1 chỉ xét em diện ưu tiên (D); lượt 2 xét mọi em còn lại theo thứ hạng (A, B). Suất ưu tiên là suất mềm: nếu không có em nào thuộc diện thì suất tự chuyển sang lượt chung (khi đó kết quả là A, B, C).</a:t>
+              <a:t>Ví dụ chạy thật bằng hàm lựa chọn của phần mềm (club_choice_function): 6 em A–F cùng đăng ký một CLB, sức chứa 2, 1 suất dự trữ (ưu tiên), chỉ C thuộc diện ưu tiên. Xếp hạng: Tầng 1 (đã thi) theo điểm, hoà điểm mới tới số bốc thăm; Tầng 2 (không thi) thuần số bốc thăm; Tầng 1 luôn trước Tầng 2. Chia suất hai lượt: lượt 1 chỉ xét em diện ưu tiên (C); lượt 2 xét mọi em còn lại theo thứ hạng (A). B xếp trên C nhưng hết chỗ vì C đã lấy suất ưu tiên. Suất ưu tiên là suất mềm: nếu không có em nào thuộc diện thì suất tự chuyển sang lượt chung (khi đó kết quả là A, B).</a:t>
             </a:r>
             <a:endParaRPr lang="en-US" dirty="0"/>
           </a:p>
@@ -947,7 +947,7 @@
                 <a:ea typeface="Calibri" pitchFamily="34" charset="-122"/>
                 <a:cs typeface="Calibri" pitchFamily="34" charset="-120"/>
               </a:rPr>
-              <a:t>Ví dụ: 6 em cùng đăng ký một câu lạc bộ nhận 3 em — 1 suất ưu tiên và 2 suất chung</a:t>
+              <a:t>Ví dụ: 6 em cùng đăng ký một câu lạc bộ nhận 2 em — 1 suất ưu tiên và 1 suất chung</a:t>
             </a:r>
             <a:endParaRPr lang="en-US" sz="1400" dirty="0"/>
           </a:p>
@@ -1469,7 +1469,7 @@
             <a:avLst/>
           </a:prstGeom>
           <a:solidFill>
-            <a:srgbClr val="3F6B52"/>
+            <a:srgbClr val="A8700F"/>
           </a:solidFill>
           <a:ln/>
         </p:spPr>
@@ -1529,6 +1529,20 @@
                 <a:cs typeface="Calibri" pitchFamily="34" charset="-120"/>
               </a:rPr>
               <a:t>điểm 8,5</a:t>
+            </a:r>
+            <a:pPr indent="0" marL="0">
+              <a:buNone/>
+            </a:pPr>
+            <a:r>
+              <a:rPr lang="en-US" sz="1300" b="1" dirty="0">
+                <a:solidFill>
+                  <a:srgbClr val="A8700F"/>
+                </a:solidFill>
+                <a:latin typeface="Calibri" pitchFamily="34" charset="0"/>
+                <a:ea typeface="Calibri" pitchFamily="34" charset="-122"/>
+                <a:cs typeface="Calibri" pitchFamily="34" charset="-120"/>
+              </a:rPr>
+              <a:t>  ·  ưu tiên</a:t>
             </a:r>
             <a:endParaRPr lang="en-US" sz="1300" dirty="0"/>
           </a:p>
@@ -1693,7 +1707,7 @@
             <a:avLst/>
           </a:prstGeom>
           <a:solidFill>
-            <a:srgbClr val="A8700F"/>
+            <a:srgbClr val="3F6B52"/>
           </a:solidFill>
           <a:ln/>
         </p:spPr>
@@ -1753,20 +1767,6 @@
                 <a:cs typeface="Calibri" pitchFamily="34" charset="-120"/>
               </a:rPr>
               <a:t>bốc thăm #2</a:t>
-            </a:r>
-            <a:pPr indent="0" marL="0">
-              <a:buNone/>
-            </a:pPr>
-            <a:r>
-              <a:rPr lang="en-US" sz="1300" b="1" dirty="0">
-                <a:solidFill>
-                  <a:srgbClr val="A8700F"/>
-                </a:solidFill>
-                <a:latin typeface="Calibri" pitchFamily="34" charset="0"/>
-                <a:ea typeface="Calibri" pitchFamily="34" charset="-122"/>
-                <a:cs typeface="Calibri" pitchFamily="34" charset="-120"/>
-              </a:rPr>
-              <a:t>  ·  ưu tiên</a:t>
             </a:r>
             <a:endParaRPr lang="en-US" sz="1300" dirty="0"/>
           </a:p>
@@ -2290,7 +2290,7 @@
       </p:sp>
       <p:sp>
         <p:nvSpPr>
-          <p:cNvPr id="39" name="Ô suất D"/>
+          <p:cNvPr id="39" name="Ô suất C"/>
           <p:cNvSpPr/>
           <p:nvPr/>
         </p:nvSpPr>
@@ -2317,7 +2317,7 @@
       </p:sp>
       <p:sp>
         <p:nvSpPr>
-          <p:cNvPr id="40" name="Chip D (kết quả)"/>
+          <p:cNvPr id="40" name="Chip C (kết quả)"/>
           <p:cNvSpPr/>
           <p:nvPr/>
         </p:nvSpPr>
@@ -2350,7 +2350,7 @@
                 <a:ea typeface="Calibri" pitchFamily="34" charset="-122"/>
                 <a:cs typeface="Calibri" pitchFamily="34" charset="-120"/>
               </a:rPr>
-              <a:t>D</a:t>
+              <a:t>C</a:t>
             </a:r>
             <a:endParaRPr lang="en-US" sz="1800" dirty="0"/>
           </a:p>
@@ -2450,7 +2450,7 @@
                 <a:ea typeface="Calibri" pitchFamily="34" charset="-122"/>
                 <a:cs typeface="Calibri" pitchFamily="34" charset="-120"/>
               </a:rPr>
-              <a:t>Suất chung · 2 suất</a:t>
+              <a:t>Suất chung · 1 suất</a:t>
             </a:r>
             <a:endParaRPr lang="en-US" sz="1500" dirty="0"/>
           </a:p>
@@ -2503,7 +2503,7 @@
         </p:nvSpPr>
         <p:spPr>
           <a:xfrm>
-            <a:off x="7077456" y="3072384"/>
+            <a:off x="7845552" y="3072384"/>
             <a:ext cx="658368" cy="658368"/>
           </a:xfrm>
           <a:prstGeom prst="roundRect">
@@ -2530,74 +2530,6 @@
         </p:nvSpPr>
         <p:spPr>
           <a:xfrm>
-            <a:off x="7178040" y="3172968"/>
-            <a:ext cx="457200" cy="457200"/>
-          </a:xfrm>
-          <a:prstGeom prst="ellipse">
-            <a:avLst/>
-          </a:prstGeom>
-          <a:solidFill>
-            <a:srgbClr val="3F6B52"/>
-          </a:solidFill>
-          <a:ln/>
-        </p:spPr>
-        <p:txBody>
-          <a:bodyPr wrap="square" lIns="0" tIns="0" rIns="0" bIns="0" rtlCol="0" anchor="ctr"/>
-          <a:lstStyle/>
-          <a:p>
-            <a:pPr algn="ctr" indent="0" marL="0">
-              <a:buNone/>
-            </a:pPr>
-            <a:r>
-              <a:rPr lang="en-US" sz="1800" b="1" dirty="0">
-                <a:solidFill>
-                  <a:srgbClr val="FFFFFF"/>
-                </a:solidFill>
-                <a:latin typeface="Calibri" pitchFamily="34" charset="0"/>
-                <a:ea typeface="Calibri" pitchFamily="34" charset="-122"/>
-                <a:cs typeface="Calibri" pitchFamily="34" charset="-120"/>
-              </a:rPr>
-              <a:t>A</a:t>
-            </a:r>
-            <a:endParaRPr lang="en-US" sz="1800" dirty="0"/>
-          </a:p>
-        </p:txBody>
-      </p:sp>
-      <p:sp>
-        <p:nvSpPr>
-          <p:cNvPr id="47" name="Ô suất B"/>
-          <p:cNvSpPr/>
-          <p:nvPr/>
-        </p:nvSpPr>
-        <p:spPr>
-          <a:xfrm>
-            <a:off x="7845552" y="3072384"/>
-            <a:ext cx="658368" cy="658368"/>
-          </a:xfrm>
-          <a:prstGeom prst="roundRect">
-            <a:avLst>
-              <a:gd name="adj" fmla="val 13889"/>
-            </a:avLst>
-          </a:prstGeom>
-          <a:solidFill>
-            <a:srgbClr val="FFFFFF"/>
-          </a:solidFill>
-          <a:ln w="19050">
-            <a:solidFill>
-              <a:srgbClr val="3F6B52"/>
-            </a:solidFill>
-            <a:prstDash val="solid"/>
-          </a:ln>
-        </p:spPr>
-      </p:sp>
-      <p:sp>
-        <p:nvSpPr>
-          <p:cNvPr id="48" name="Chip B (kết quả)"/>
-          <p:cNvSpPr/>
-          <p:nvPr/>
-        </p:nvSpPr>
-        <p:spPr>
-          <a:xfrm>
             <a:off x="7946136" y="3172968"/>
             <a:ext cx="457200" cy="457200"/>
           </a:xfrm>
@@ -2625,7 +2557,7 @@
                 <a:ea typeface="Calibri" pitchFamily="34" charset="-122"/>
                 <a:cs typeface="Calibri" pitchFamily="34" charset="-120"/>
               </a:rPr>
-              <a:t>B</a:t>
+              <a:t>A</a:t>
             </a:r>
             <a:endParaRPr lang="en-US" sz="1800" dirty="0"/>
           </a:p>
@@ -2633,7 +2565,7 @@
       </p:sp>
       <p:sp>
         <p:nvSpPr>
-          <p:cNvPr id="49" name="Nhãn chưa có suất"/>
+          <p:cNvPr id="47" name="Nhãn chưa có suất"/>
           <p:cNvSpPr txBox="1"/>
           <p:nvPr/>
         </p:nvSpPr>
@@ -2672,7 +2604,7 @@
       </p:sp>
       <p:sp>
         <p:nvSpPr>
-          <p:cNvPr id="50" name="Chip C (chưa có suất)"/>
+          <p:cNvPr id="48" name="Chip B (chưa có suất)"/>
           <p:cNvSpPr/>
           <p:nvPr/>
         </p:nvSpPr>
@@ -2705,7 +2637,7 @@
                 <a:ea typeface="Calibri" pitchFamily="34" charset="-122"/>
                 <a:cs typeface="Calibri" pitchFamily="34" charset="-120"/>
               </a:rPr>
-              <a:t>C</a:t>
+              <a:t>B</a:t>
             </a:r>
             <a:endParaRPr lang="en-US" sz="1300" dirty="0"/>
           </a:p>
@@ -2713,7 +2645,7 @@
       </p:sp>
       <p:sp>
         <p:nvSpPr>
-          <p:cNvPr id="51" name="Chip E (chưa có suất)"/>
+          <p:cNvPr id="49" name="Chip D (chưa có suất)"/>
           <p:cNvSpPr/>
           <p:nvPr/>
         </p:nvSpPr>
@@ -2746,7 +2678,7 @@
                 <a:ea typeface="Calibri" pitchFamily="34" charset="-122"/>
                 <a:cs typeface="Calibri" pitchFamily="34" charset="-120"/>
               </a:rPr>
-              <a:t>E</a:t>
+              <a:t>D</a:t>
             </a:r>
             <a:endParaRPr lang="en-US" sz="1300" dirty="0"/>
           </a:p>
@@ -2754,7 +2686,7 @@
       </p:sp>
       <p:sp>
         <p:nvSpPr>
-          <p:cNvPr id="52" name="Chip F (chưa có suất)"/>
+          <p:cNvPr id="50" name="Chip E (chưa có suất)"/>
           <p:cNvSpPr/>
           <p:nvPr/>
         </p:nvSpPr>
@@ -2787,6 +2719,47 @@
                 <a:ea typeface="Calibri" pitchFamily="34" charset="-122"/>
                 <a:cs typeface="Calibri" pitchFamily="34" charset="-120"/>
               </a:rPr>
+              <a:t>E</a:t>
+            </a:r>
+            <a:endParaRPr lang="en-US" sz="1300" dirty="0"/>
+          </a:p>
+        </p:txBody>
+      </p:sp>
+      <p:sp>
+        <p:nvSpPr>
+          <p:cNvPr id="51" name="Chip F (chưa có suất)"/>
+          <p:cNvSpPr/>
+          <p:nvPr/>
+        </p:nvSpPr>
+        <p:spPr>
+          <a:xfrm>
+            <a:off x="7004304" y="4023360"/>
+            <a:ext cx="310896" cy="310896"/>
+          </a:xfrm>
+          <a:prstGeom prst="ellipse">
+            <a:avLst/>
+          </a:prstGeom>
+          <a:solidFill>
+            <a:srgbClr val="DBDCD5"/>
+          </a:solidFill>
+          <a:ln/>
+        </p:spPr>
+        <p:txBody>
+          <a:bodyPr wrap="square" lIns="0" tIns="0" rIns="0" bIns="0" rtlCol="0" anchor="ctr"/>
+          <a:lstStyle/>
+          <a:p>
+            <a:pPr algn="ctr" indent="0" marL="0">
+              <a:buNone/>
+            </a:pPr>
+            <a:r>
+              <a:rPr lang="en-US" sz="1300" b="1" dirty="0">
+                <a:solidFill>
+                  <a:srgbClr val="5B6570"/>
+                </a:solidFill>
+                <a:latin typeface="Calibri" pitchFamily="34" charset="0"/>
+                <a:ea typeface="Calibri" pitchFamily="34" charset="-122"/>
+                <a:cs typeface="Calibri" pitchFamily="34" charset="-120"/>
+              </a:rPr>
               <a:t>F</a:t>
             </a:r>
             <a:endParaRPr lang="en-US" sz="1300" dirty="0"/>
@@ -2795,7 +2768,7 @@
       </p:sp>
       <p:sp>
         <p:nvSpPr>
-          <p:cNvPr id="53" name="Ghi chú C"/>
+          <p:cNvPr id="52" name="Ghi chú C"/>
           <p:cNvSpPr txBox="1"/>
           <p:nvPr/>
         </p:nvSpPr>
@@ -2826,7 +2799,7 @@
                 <a:ea typeface="Calibri" pitchFamily="34" charset="-122"/>
                 <a:cs typeface="Calibri" pitchFamily="34" charset="-120"/>
               </a:rPr>
-              <a:t>C xếp trên D nhưng suất ưu tiên đã thuộc về D</a:t>
+              <a:t>B xếp trên C nhưng suất ưu tiên đã thuộc về C</a:t>
             </a:r>
             <a:endParaRPr lang="en-US" sz="1100" dirty="0"/>
           </a:p>
@@ -2834,7 +2807,7 @@
       </p:sp>
       <p:sp>
         <p:nvSpPr>
-          <p:cNvPr id="54" name="Chú giải chấm vàng"/>
+          <p:cNvPr id="53" name="Chú giải chấm vàng"/>
           <p:cNvSpPr/>
           <p:nvPr/>
         </p:nvSpPr>
@@ -2864,7 +2837,7 @@
       </p:sp>
       <p:sp>
         <p:nvSpPr>
-          <p:cNvPr id="55" name="Chú giải"/>
+          <p:cNvPr id="54" name="Chú giải"/>
           <p:cNvSpPr txBox="1"/>
           <p:nvPr/>
         </p:nvSpPr>
@@ -2903,7 +2876,7 @@
       </p:sp>
       <p:sp>
         <p:nvSpPr>
-          <p:cNvPr id="56" name="Nhãn AI"/>
+          <p:cNvPr id="55" name="Nhãn AI"/>
           <p:cNvSpPr txBox="1"/>
           <p:nvPr/>
         </p:nvSpPr>
@@ -2934,7 +2907,7 @@
                 <a:ea typeface="Calibri" pitchFamily="34" charset="-122"/>
                 <a:cs typeface="Calibri" pitchFamily="34" charset="-120"/>
               </a:rPr>
-              <a:t>Sơ đồ do AI tạo ra · Dữ liệu minh hoạ</a:t>
+              <a:t>Dữ liệu minh hoạ</a:t>
             </a:r>
             <a:endParaRPr lang="en-US" sz="1100" dirty="0"/>
           </a:p>

</xml_diff>